<commit_message>
Actualizo la diapositiva de práctica integradora con la nueva Parte 3
La diapo 29 (Práctica integradora) tenía la grilla de 2 tarjetas de
cuando se sacó el simulacro, sin reflejar el reemplazo (Parte 3 · Del
pipeline en general). Se agrega la tercera tarjeta y se regeneran el PDF
y el PPTX para que las tres versiones queden consistentes con
practica.md.

Co-Authored-By: Claude Sonnet 5 <noreply@anthropic.com>
Claude-Session: https://claude.ai/code/session_01HdsCvVJPWjVBeSRpnW1RKh
</commit_message>
<xml_diff>
--- a/clases/clase_3_pipeline_y_narrativa/Clase_3_Pipeline_y_narrativa.pptx
+++ b/clases/clase_3_pipeline_y_narrativa/Clase_3_Pipeline_y_narrativa.pptx
@@ -17133,7 +17133,7 @@
         <p:spPr>
           <a:xfrm>
             <a:off x="548640" y="1737360"/>
-            <a:ext cx="5394960" cy="1554480"/>
+            <a:ext cx="3511296" cy="1874520"/>
           </a:xfrm>
           <a:prstGeom prst="rect">
             <a:avLst/>
@@ -17181,7 +17181,7 @@
               <a:buNone/>
             </a:pPr>
             <a:r>
-              <a:rPr lang="en-US" sz="1250" dirty="0">
+              <a:rPr lang="en-US" sz="1100" dirty="0">
                 <a:solidFill>
                   <a:srgbClr val="595959"/>
                 </a:solidFill>
@@ -17203,8 +17203,8 @@
         </p:nvSpPr>
         <p:spPr>
           <a:xfrm>
-            <a:off x="6263640" y="1737360"/>
-            <a:ext cx="5394960" cy="1554480"/>
+            <a:off x="4334256" y="1737360"/>
+            <a:ext cx="3511296" cy="1874520"/>
           </a:xfrm>
           <a:prstGeom prst="rect">
             <a:avLst/>
@@ -17252,7 +17252,7 @@
               <a:buNone/>
             </a:pPr>
             <a:r>
-              <a:rPr lang="en-US" sz="1250" dirty="0">
+              <a:rPr lang="en-US" sz="1100" dirty="0">
                 <a:solidFill>
                   <a:srgbClr val="595959"/>
                 </a:solidFill>
@@ -17274,7 +17274,78 @@
         </p:nvSpPr>
         <p:spPr>
           <a:xfrm>
-            <a:off x="548640" y="3520440"/>
+            <a:off x="8119872" y="1737360"/>
+            <a:ext cx="3511296" cy="1874520"/>
+          </a:xfrm>
+          <a:prstGeom prst="rect">
+            <a:avLst/>
+          </a:prstGeom>
+          <a:solidFill>
+            <a:srgbClr val="FFFFFF"/>
+          </a:solidFill>
+          <a:ln w="12700">
+            <a:solidFill>
+              <a:srgbClr val="D9D9D9"/>
+            </a:solidFill>
+          </a:ln>
+        </p:spPr>
+        <p:txBody>
+          <a:bodyPr wrap="square" lIns="127000" tIns="127000" rIns="127000" bIns="127000" rtlCol="0" anchor="t"/>
+          <a:lstStyle/>
+          <a:p>
+            <a:pPr algn="l" indent="0" marL="0">
+              <a:lnSpc>
+                <a:spcPct val="115000"/>
+              </a:lnSpc>
+              <a:spcAft>
+                <a:spcPts val="600"/>
+              </a:spcAft>
+              <a:buNone/>
+            </a:pPr>
+            <a:r>
+              <a:rPr lang="en-US" sz="1050" b="1" dirty="0">
+                <a:solidFill>
+                  <a:srgbClr val="262626"/>
+                </a:solidFill>
+                <a:latin typeface="Arial" pitchFamily="34" charset="0"/>
+                <a:ea typeface="Arial" pitchFamily="34" charset="-122"/>
+                <a:cs typeface="Arial" pitchFamily="34" charset="-120"/>
+              </a:rPr>
+              <a:t>3 · DEL PIPELINE EN GENERAL</a:t>
+            </a:r>
+            <a:endParaRPr lang="en-US" sz="1050" dirty="0"/>
+          </a:p>
+          <a:p>
+            <a:pPr algn="l" indent="0" marL="0">
+              <a:lnSpc>
+                <a:spcPct val="115000"/>
+              </a:lnSpc>
+              <a:buNone/>
+            </a:pPr>
+            <a:r>
+              <a:rPr lang="en-US" sz="1100" dirty="0">
+                <a:solidFill>
+                  <a:srgbClr val="595959"/>
+                </a:solidFill>
+                <a:latin typeface="Arial" pitchFamily="34" charset="0"/>
+                <a:ea typeface="Arial" pitchFamily="34" charset="-122"/>
+                <a:cs typeface="Arial" pitchFamily="34" charset="-120"/>
+              </a:rPr>
+              <a:t>Mapear la cadena de un indicador nuevo (tasa de empleo) y decidir en qué archivo tocaría cada cambio — sin correr nada.</a:t>
+            </a:r>
+            <a:endParaRPr lang="en-US" sz="1050" dirty="0"/>
+          </a:p>
+        </p:txBody>
+      </p:sp>
+      <p:sp>
+        <p:nvSpPr>
+          <p:cNvPr id="7" name="Text 5"/>
+          <p:cNvSpPr txBox="1"/>
+          <p:nvPr/>
+        </p:nvSpPr>
+        <p:spPr>
+          <a:xfrm>
+            <a:off x="548640" y="3794760"/>
             <a:ext cx="11094415" cy="365760"/>
           </a:xfrm>
           <a:prstGeom prst="rect">
@@ -17344,7 +17415,7 @@
       </p:sp>
       <p:sp>
         <p:nvSpPr>
-          <p:cNvPr id="7" name="Text 5"/>
+          <p:cNvPr id="8" name="Text 6"/>
           <p:cNvSpPr txBox="1"/>
           <p:nvPr/>
         </p:nvSpPr>

</xml_diff>